<commit_message>
Update DCAD Practical Data Application.pptx
</commit_message>
<xml_diff>
--- a/DCAD Practical Data Application.pptx
+++ b/DCAD Practical Data Application.pptx
@@ -12345,7 +12345,7 @@
               <a:latin typeface="+mn-lt"/>
               <a:ea typeface="+mn-ea"/>
               <a:cs typeface="+mn-cs"/>
-              <a:hlinkClick xmlns:r="http://schemas.openxmlformats.org/officeDocument/2006/relationships" r:id="rId5"/>
+              <a:hlinkClick xmlns:r="http://schemas.openxmlformats.org/officeDocument/2006/relationships" r:id="rId5" action="ppaction://hlinkfile"/>
             </a:rPr>
             <a:t>Audit Verification Requests</a:t>
           </a:r>
@@ -12924,7 +12924,7 @@
           <a:r>
             <a:rPr lang="en-US" sz="1400" kern="1200" noProof="1">
               <a:latin typeface="+mn-lt"/>
-              <a:hlinkClick xmlns:r="http://schemas.openxmlformats.org/officeDocument/2006/relationships" r:id="rId7"/>
+              <a:hlinkClick xmlns:r="http://schemas.openxmlformats.org/officeDocument/2006/relationships" r:id="rId7" action="ppaction://hlinkfile"/>
             </a:rPr>
             <a:t>Ad Hoc Requests</a:t>
           </a:r>
@@ -13159,7 +13159,7 @@
           <a:r>
             <a:rPr lang="en-US" sz="1400" kern="1200" dirty="0">
               <a:latin typeface="+mn-lt"/>
-              <a:hlinkClick xmlns:r="http://schemas.openxmlformats.org/officeDocument/2006/relationships" r:id="rId8"/>
+              <a:hlinkClick xmlns:r="http://schemas.openxmlformats.org/officeDocument/2006/relationships" r:id="rId8" action="ppaction://hlinkfile"/>
             </a:rPr>
             <a:t>Statistical Analysis</a:t>
           </a:r>
@@ -23222,7 +23222,7 @@
           <a:p>
             <a:fld id="{F352A77B-D33C-49B3-A83C-450AA2ED72B3}" type="datetimeFigureOut">
               <a:rPr lang="en-US" smtClean="0"/>
-              <a:t>11/19/2025</a:t>
+              <a:t>11/20/2025</a:t>
             </a:fld>
             <a:endParaRPr lang="en-US" dirty="0"/>
           </a:p>
@@ -23399,7 +23399,7 @@
           <a:p>
             <a:fld id="{E38D8F9A-F5CB-4EF8-A859-ED5E107B9763}" type="datetimeFigureOut">
               <a:rPr lang="en-US" smtClean="0"/>
-              <a:t>11/19/2025</a:t>
+              <a:t>11/20/2025</a:t>
             </a:fld>
             <a:endParaRPr lang="en-US" dirty="0"/>
           </a:p>
@@ -24214,6 +24214,14 @@
           <a:bodyPr/>
           <a:lstStyle/>
           <a:p>
+            <a:r>
+              <a:rPr lang="en-US" dirty="0"/>
+              <a:t>254 counties 253 appraisal districts potter-</a:t>
+            </a:r>
+            <a:r>
+              <a:rPr lang="en-US"/>
+              <a:t>randall</a:t>
+            </a:r>
             <a:endParaRPr lang="en-US" dirty="0"/>
           </a:p>
         </p:txBody>
@@ -35047,6 +35055,15 @@
 </file>
 
 <file path=customXml/item1.xml><?xml version="1.0" encoding="utf-8"?>
+<?mso-contentType ?>
+<FormTemplates xmlns="http://schemas.microsoft.com/sharepoint/v3/contenttype/forms">
+  <Display>DocumentLibraryForm</Display>
+  <Edit>DocumentLibraryForm</Edit>
+  <New>DocumentLibraryForm</New>
+</FormTemplates>
+</file>
+
+<file path=customXml/item2.xml><?xml version="1.0" encoding="utf-8"?>
 <ct:contentTypeSchema xmlns:ct="http://schemas.microsoft.com/office/2006/metadata/contentType" xmlns:ma="http://schemas.microsoft.com/office/2006/metadata/properties/metaAttributes" ct:_="" ma:_="" ma:contentTypeName="Document" ma:contentTypeID="0x01010079F111ED35F8CC479449609E8A0923A6" ma:contentTypeVersion="28" ma:contentTypeDescription="Create a new document." ma:contentTypeScope="" ma:versionID="60f5a4f2d2b0abadcf532d48ebf9cb71">
   <xsd:schema xmlns:xsd="http://www.w3.org/2001/XMLSchema" xmlns:xs="http://www.w3.org/2001/XMLSchema" xmlns:p="http://schemas.microsoft.com/office/2006/metadata/properties" xmlns:ns1="http://schemas.microsoft.com/sharepoint/v3" xmlns:ns2="71af3243-3dd4-4a8d-8c0d-dd76da1f02a5" xmlns:ns3="16c05727-aa75-4e4a-9b5f-8a80a1165891" xmlns:ns4="230e9df3-be65-4c73-a93b-d1236ebd677e" targetNamespace="http://schemas.microsoft.com/office/2006/metadata/properties" ma:root="true" ma:fieldsID="7dd78129e6a1811f84807ad11c651531" ns1:_="" ns2:_="" ns3:_="" ns4:_="">
     <xsd:import namespace="http://schemas.microsoft.com/sharepoint/v3"/>
@@ -35358,15 +35375,6 @@
 </ct:contentTypeSchema>
 </file>
 
-<file path=customXml/item2.xml><?xml version="1.0" encoding="utf-8"?>
-<?mso-contentType ?>
-<FormTemplates xmlns="http://schemas.microsoft.com/sharepoint/v3/contenttype/forms">
-  <Display>DocumentLibraryForm</Display>
-  <Edit>DocumentLibraryForm</Edit>
-  <New>DocumentLibraryForm</New>
-</FormTemplates>
-</file>
-
 <file path=customXml/item3.xml><?xml version="1.0" encoding="utf-8"?>
 <p:properties xmlns:p="http://schemas.microsoft.com/office/2006/metadata/properties" xmlns:xsi="http://www.w3.org/2001/XMLSchema-instance" xmlns:pc="http://schemas.microsoft.com/office/infopath/2007/PartnerControls">
   <documentManagement>
@@ -35388,6 +35396,14 @@
 </file>
 
 <file path=customXml/itemProps1.xml><?xml version="1.0" encoding="utf-8"?>
+<ds:datastoreItem xmlns:ds="http://schemas.openxmlformats.org/officeDocument/2006/customXml" ds:itemID="{B7B39BD0-040C-43BE-B0E4-512B09E8003F}">
+  <ds:schemaRefs>
+    <ds:schemaRef ds:uri="http://schemas.microsoft.com/sharepoint/v3/contenttype/forms"/>
+  </ds:schemaRefs>
+</ds:datastoreItem>
+</file>
+
+<file path=customXml/itemProps2.xml><?xml version="1.0" encoding="utf-8"?>
 <ds:datastoreItem xmlns:ds="http://schemas.openxmlformats.org/officeDocument/2006/customXml" ds:itemID="{622457D9-12AC-4794-A05E-F1B90FCD8DA7}">
   <ds:schemaRefs>
     <ds:schemaRef ds:uri="http://schemas.microsoft.com/office/2006/metadata/contentType"/>
@@ -35408,14 +35424,6 @@
 </ds:datastoreItem>
 </file>
 
-<file path=customXml/itemProps2.xml><?xml version="1.0" encoding="utf-8"?>
-<ds:datastoreItem xmlns:ds="http://schemas.openxmlformats.org/officeDocument/2006/customXml" ds:itemID="{B7B39BD0-040C-43BE-B0E4-512B09E8003F}">
-  <ds:schemaRefs>
-    <ds:schemaRef ds:uri="http://schemas.microsoft.com/sharepoint/v3/contenttype/forms"/>
-  </ds:schemaRefs>
-</ds:datastoreItem>
-</file>
-
 <file path=customXml/itemProps3.xml><?xml version="1.0" encoding="utf-8"?>
 <ds:datastoreItem xmlns:ds="http://schemas.openxmlformats.org/officeDocument/2006/customXml" ds:itemID="{AB045227-5724-4DBF-9712-031B1BFB2C3C}">
   <ds:schemaRefs>

</xml_diff>